<commit_message>
Unificar severidad de Supabase (INFO) y corregir referencias cruzadas en todos los documentos
</commit_message>
<xml_diff>
--- a/Presentacion_BiciPop_Final.pptx
+++ b/Presentacion_BiciPop_Final.pptx
@@ -2570,7 +2570,7 @@
                 <a:ea typeface="Calibri" pitchFamily="34" charset="-122"/>
                 <a:cs typeface="Calibri" pitchFamily="34" charset="-120"/>
               </a:rPr>
-              <a:t>2</a:t>
+              <a:t>1</a:t>
             </a:r>
             <a:endParaRPr lang="en-US" sz="7200" dirty="0"/>
           </a:p>
@@ -2682,7 +2682,7 @@
                 <a:ea typeface="Calibri" pitchFamily="34" charset="-122"/>
                 <a:cs typeface="Calibri" pitchFamily="34" charset="-120"/>
               </a:rPr>
-              <a:t>1</a:t>
+              <a:t>2</a:t>
             </a:r>
             <a:endParaRPr lang="en-US" sz="7200" dirty="0"/>
           </a:p>
@@ -5662,7 +5662,7 @@
                 <a:ea typeface="Calibri" pitchFamily="34" charset="-122"/>
                 <a:cs typeface="Calibri" pitchFamily="34" charset="-120"/>
               </a:rPr>
-              <a:t>MEDIO</a:t>
+              <a:t>INFO</a:t>
             </a:r>
             <a:endParaRPr lang="en-US" sz="1200" dirty="0"/>
           </a:p>

</xml_diff>